<commit_message>
fix(slides): give Two Content body text the master size
The built-in design's Two Content layout set its own 28 pt body text while
every other content layout inherited the master's 20 pt, so a Markdown slide
with text and a picture had larger text than a bullet slide. The layout now
inherits the master's body style. The design-system reference says what to
do when a supplied template's layouts disagree, since the CLI does not edit
masters or layouts.
</commit_message>
<xml_diff>
--- a/src/Aspose.Cli.Product.Slides/Engine/Templates/default-16x9.pptx
+++ b/src/Aspose.Cli.Product.Slides/Engine/Templates/default-16x9.pptx
@@ -653,35 +653,7 @@
         </p:spPr>
         <p:txBody>
           <a:bodyPr anchor="t"/>
-          <a:lstStyle>
-            <a:lvl1pPr>
-              <a:defRPr sz="2800"/>
-            </a:lvl1pPr>
-            <a:lvl2pPr>
-              <a:defRPr sz="2400"/>
-            </a:lvl2pPr>
-            <a:lvl3pPr>
-              <a:defRPr sz="2000"/>
-            </a:lvl3pPr>
-            <a:lvl4pPr>
-              <a:defRPr sz="1800"/>
-            </a:lvl4pPr>
-            <a:lvl5pPr>
-              <a:defRPr sz="1800"/>
-            </a:lvl5pPr>
-            <a:lvl6pPr>
-              <a:defRPr sz="1800"/>
-            </a:lvl6pPr>
-            <a:lvl7pPr>
-              <a:defRPr sz="1800"/>
-            </a:lvl7pPr>
-            <a:lvl8pPr>
-              <a:defRPr sz="1800"/>
-            </a:lvl8pPr>
-            <a:lvl9pPr>
-              <a:defRPr sz="1800"/>
-            </a:lvl9pPr>
-          </a:lstStyle>
+          <a:lstStyle/>
           <a:p>
             <a:r>
               <a:rPr lang="en-US" smtClean="0"/>
@@ -737,35 +709,7 @@
         </p:spPr>
         <p:txBody>
           <a:bodyPr anchor="t"/>
-          <a:lstStyle>
-            <a:lvl1pPr>
-              <a:defRPr sz="2800"/>
-            </a:lvl1pPr>
-            <a:lvl2pPr>
-              <a:defRPr sz="2400"/>
-            </a:lvl2pPr>
-            <a:lvl3pPr>
-              <a:defRPr sz="2000"/>
-            </a:lvl3pPr>
-            <a:lvl4pPr>
-              <a:defRPr sz="1800"/>
-            </a:lvl4pPr>
-            <a:lvl5pPr>
-              <a:defRPr sz="1800"/>
-            </a:lvl5pPr>
-            <a:lvl6pPr>
-              <a:defRPr sz="1800"/>
-            </a:lvl6pPr>
-            <a:lvl7pPr>
-              <a:defRPr sz="1800"/>
-            </a:lvl7pPr>
-            <a:lvl8pPr>
-              <a:defRPr sz="1800"/>
-            </a:lvl8pPr>
-            <a:lvl9pPr>
-              <a:defRPr sz="1800"/>
-            </a:lvl9pPr>
-          </a:lstStyle>
+          <a:lstStyle/>
           <a:p>
             <a:r>
               <a:rPr lang="en-US" smtClean="0"/>

</xml_diff>